<commit_message>
Align slide 17 capital structure to GIS two-column grid
Snap left column to 0.50×6.15 and right WACC panel to 6.85×6.00 so
section headers, tables, grey panel, navy WACC box, and source-map
tables share the same edges as slide 20 DCF layout.

Co-authored-by: cag56988 <cag56988@usc.edu>
</commit_message>
<xml_diff>
--- a/LULU/GIS IR LULU.pptx
+++ b/LULU/GIS IR LULU.pptx
@@ -16210,7 +16210,7 @@
         <p:spPr>
           <a:xfrm>
             <a:off x="457200" y="1133856"/>
-            <a:ext cx="5486400" cy="201168"/>
+            <a:ext cx="5623560" cy="201168"/>
           </a:xfrm>
           <a:prstGeom prst="rect">
             <a:avLst/>
@@ -16253,8 +16253,8 @@
         </p:nvSpPr>
         <p:spPr>
           <a:xfrm>
-            <a:off x="6126480" y="1133856"/>
-            <a:ext cx="5623560" cy="201168"/>
+            <a:off x="6263640" y="1133856"/>
+            <a:ext cx="5486400" cy="201168"/>
           </a:xfrm>
           <a:prstGeom prst="rect">
             <a:avLst/>
@@ -16299,7 +16299,7 @@
         </p:nvGraphicFramePr>
         <p:xfrm>
           <a:off x="457200" y="1353312"/>
-          <a:ext cx="5532118" cy="1234440"/>
+          <a:ext cx="5623560" cy="1234440"/>
         </p:xfrm>
         <a:graphic>
           <a:graphicData uri="http://schemas.openxmlformats.org/drawingml/2006/table">
@@ -16680,7 +16680,7 @@
         <p:spPr>
           <a:xfrm>
             <a:off x="457200" y="2615184"/>
-            <a:ext cx="5532120" cy="182880"/>
+            <a:ext cx="5623560" cy="182880"/>
           </a:xfrm>
           <a:prstGeom prst="rect">
             <a:avLst/>
@@ -16725,7 +16725,7 @@
         </p:nvGraphicFramePr>
         <p:xfrm>
           <a:off x="457200" y="2816352"/>
-          <a:ext cx="5532118" cy="713232"/>
+          <a:ext cx="5623560" cy="713232"/>
         </p:xfrm>
         <a:graphic>
           <a:graphicData uri="http://schemas.openxmlformats.org/drawingml/2006/table">
@@ -16964,7 +16964,7 @@
         <p:spPr>
           <a:xfrm>
             <a:off x="457200" y="3858768"/>
-            <a:ext cx="5532120" cy="438912"/>
+            <a:ext cx="5623560" cy="438912"/>
           </a:xfrm>
           <a:prstGeom prst="rect">
             <a:avLst/>
@@ -17007,8 +17007,8 @@
         </p:nvSpPr>
         <p:spPr>
           <a:xfrm>
-            <a:off x="6126480" y="1371600"/>
-            <a:ext cx="5623560" cy="3227832"/>
+            <a:off x="6263640" y="1371600"/>
+            <a:ext cx="5486400" cy="3227832"/>
           </a:xfrm>
           <a:prstGeom prst="rect">
             <a:avLst/>
@@ -17038,8 +17038,8 @@
           <p:nvPr/>
         </p:nvGraphicFramePr>
         <p:xfrm>
-          <a:off x="6199632" y="1426464"/>
-          <a:ext cx="5468112" cy="2029968"/>
+          <a:off x="6263640" y="1426464"/>
+          <a:ext cx="5486400" cy="2029968"/>
         </p:xfrm>
         <a:graphic>
           <a:graphicData uri="http://schemas.openxmlformats.org/drawingml/2006/table">
@@ -17496,7 +17496,7 @@
         <p:spPr>
           <a:xfrm>
             <a:off x="6263640" y="3547872"/>
-            <a:ext cx="5349240" cy="219456"/>
+            <a:ext cx="5486400" cy="219456"/>
           </a:xfrm>
           <a:prstGeom prst="rect">
             <a:avLst/>
@@ -17539,8 +17539,8 @@
         </p:nvSpPr>
         <p:spPr>
           <a:xfrm>
-            <a:off x="6126480" y="3785615"/>
-            <a:ext cx="5623560" cy="768096"/>
+            <a:off x="6263640" y="3785615"/>
+            <a:ext cx="5486400" cy="768096"/>
           </a:xfrm>
           <a:prstGeom prst="rect">
             <a:avLst/>
@@ -17654,7 +17654,7 @@
         </p:nvGraphicFramePr>
         <p:xfrm>
           <a:off x="457200" y="4809744"/>
-          <a:ext cx="5532120" cy="658364"/>
+          <a:ext cx="5623560" cy="658364"/>
         </p:xfrm>
         <a:graphic>
           <a:graphicData uri="http://schemas.openxmlformats.org/drawingml/2006/table">
@@ -18015,8 +18015,8 @@
           <p:nvPr/>
         </p:nvGraphicFramePr>
         <p:xfrm>
-          <a:off x="6199632" y="4809744"/>
-          <a:ext cx="5468112" cy="987550"/>
+          <a:off x="6263640" y="4809744"/>
+          <a:ext cx="5486400" cy="987550"/>
         </p:xfrm>
         <a:graphic>
           <a:graphicData uri="http://schemas.openxmlformats.org/drawingml/2006/table">

</xml_diff>

<commit_message>
Remove NOPAT references and GIS PM-discretion disclaimer from deck
Drop the cover-slide boilerplate about adding/removing content slides.
Scrub NOPAT Bridge mentions from Links & Sources footnotes; wire scrub
into the GIS compliance pipeline.

Co-authored-by: cag56988 <cag56988@usc.edu>
</commit_message>
<xml_diff>
--- a/LULU/GIS IR LULU.pptx
+++ b/LULU/GIS IR LULU.pptx
@@ -3366,8 +3366,8 @@
         </p:nvSpPr>
         <p:spPr>
           <a:xfrm>
-            <a:off x="502920" y="5806440"/>
-            <a:ext cx="7772400" cy="868680"/>
+            <a:off x="502920" y="6144768"/>
+            <a:ext cx="5029200" cy="320040"/>
           </a:xfrm>
           <a:prstGeom prst="rect">
             <a:avLst/>
@@ -3375,7 +3375,7 @@
           <a:noFill/>
         </p:spPr>
         <p:txBody>
-          <a:bodyPr wrap="square">
+          <a:bodyPr wrap="none">
             <a:spAutoFit/>
           </a:bodyPr>
           <a:lstStyle/>
@@ -3389,23 +3389,6 @@
                 <a:cs typeface="Garamond"/>
               </a:rPr>
               <a:t>Investment Research Division</a:t>
-            </a:r>
-          </a:p>
-          <a:p>
-            <a:pPr>
-              <a:spcBef>
-                <a:spcPts val="400"/>
-              </a:spcBef>
-            </a:pPr>
-            <a:r>
-              <a:rPr sz="950" b="0" i="1">
-                <a:solidFill>
-                  <a:srgbClr val="FFFFFF"/>
-                </a:solidFill>
-                <a:latin typeface="Garamond"/>
-                <a:cs typeface="Garamond"/>
-              </a:rPr>
-              <a:t>Content slides can be added / removed depending on the investment opportunity (PM discretion).</a:t>
             </a:r>
           </a:p>
         </p:txBody>
@@ -3664,27 +3647,7 @@
             <a:spAutoFit/>
           </a:bodyPr>
           <a:lstStyle/>
-          <a:p>
-            <a:pPr algn="l">
-              <a:spcBef>
-                <a:spcPts val="0"/>
-              </a:spcBef>
-              <a:spcAft>
-                <a:spcPts val="0"/>
-              </a:spcAft>
-              <a:buNone/>
-            </a:pPr>
-            <a:r>
-              <a:rPr sz="800" b="0" i="0">
-                <a:solidFill>
-                  <a:srgbClr val="8C8C8C"/>
-                </a:solidFill>
-                <a:latin typeface="Garamond"/>
-                <a:cs typeface="Garamond"/>
-              </a:rPr>
-              <a:t> </a:t>
-            </a:r>
-          </a:p>
+          <a:p/>
         </p:txBody>
       </p:sp>
       <p:sp>
@@ -4262,16 +4225,8 @@
           <a:bodyPr rtlCol="0" anchor="ctr" wrap="square" tIns="12700" bIns="12700" lIns="101600" rIns="101600"/>
           <a:lstStyle/>
           <a:p>
-            <a:pPr algn="r"/>
-            <a:r>
-              <a:rPr sz="1200" b="1" i="0">
-                <a:solidFill>
-                  <a:srgbClr val="FFFFFF"/>
-                </a:solidFill>
-                <a:latin typeface="Garamond"/>
-                <a:cs typeface="Garamond"/>
-              </a:rPr>
-              <a:t>Investment Thesis II  Partial Margin Recovery &amp; Brand Loyalty Floor</a:t>
+            <a:r>
+              <a:t>Investment Thesis II Partial Margin Recovery &amp; Brand Loyalty Floor</a:t>
             </a:r>
           </a:p>
         </p:txBody>
@@ -4371,27 +4326,7 @@
             <a:spAutoFit/>
           </a:bodyPr>
           <a:lstStyle/>
-          <a:p>
-            <a:pPr algn="l">
-              <a:spcBef>
-                <a:spcPts val="0"/>
-              </a:spcBef>
-              <a:spcAft>
-                <a:spcPts val="0"/>
-              </a:spcAft>
-              <a:buNone/>
-            </a:pPr>
-            <a:r>
-              <a:rPr sz="800" b="0" i="0">
-                <a:solidFill>
-                  <a:srgbClr val="8C8C8C"/>
-                </a:solidFill>
-                <a:latin typeface="Garamond"/>
-                <a:cs typeface="Garamond"/>
-              </a:rPr>
-              <a:t> </a:t>
-            </a:r>
-          </a:p>
+          <a:p/>
         </p:txBody>
       </p:sp>
       <p:sp>
@@ -5204,27 +5139,7 @@
             <a:spAutoFit/>
           </a:bodyPr>
           <a:lstStyle/>
-          <a:p>
-            <a:pPr algn="l">
-              <a:spcBef>
-                <a:spcPts val="0"/>
-              </a:spcBef>
-              <a:spcAft>
-                <a:spcPts val="0"/>
-              </a:spcAft>
-              <a:buNone/>
-            </a:pPr>
-            <a:r>
-              <a:rPr sz="800" b="0" i="0">
-                <a:solidFill>
-                  <a:srgbClr val="8C8C8C"/>
-                </a:solidFill>
-                <a:latin typeface="Garamond"/>
-                <a:cs typeface="Garamond"/>
-              </a:rPr>
-              <a:t> </a:t>
-            </a:r>
-          </a:p>
+          <a:p/>
         </p:txBody>
       </p:sp>
       <p:sp>
@@ -5911,27 +5826,7 @@
             <a:spAutoFit/>
           </a:bodyPr>
           <a:lstStyle/>
-          <a:p>
-            <a:pPr algn="l">
-              <a:spcBef>
-                <a:spcPts val="0"/>
-              </a:spcBef>
-              <a:spcAft>
-                <a:spcPts val="0"/>
-              </a:spcAft>
-              <a:buNone/>
-            </a:pPr>
-            <a:r>
-              <a:rPr sz="800" b="0" i="0">
-                <a:solidFill>
-                  <a:srgbClr val="8C8C8C"/>
-                </a:solidFill>
-                <a:latin typeface="Garamond"/>
-                <a:cs typeface="Garamond"/>
-              </a:rPr>
-              <a:t> </a:t>
-            </a:r>
-          </a:p>
+          <a:p/>
         </p:txBody>
       </p:sp>
       <p:sp>
@@ -6312,89 +6207,22 @@
           </a:bodyPr>
           <a:lstStyle/>
           <a:p>
-            <a:pPr algn="l">
-              <a:spcBef>
-                <a:spcPts val="0"/>
-              </a:spcBef>
-              <a:spcAft>
-                <a:spcPts val="100"/>
-              </a:spcAft>
-              <a:buNone/>
-            </a:pPr>
-            <a:r>
-              <a:rPr sz="800" b="1" i="0">
-                <a:solidFill>
-                  <a:srgbClr val="990000"/>
-                </a:solidFill>
-                <a:latin typeface="Garamond"/>
-                <a:cs typeface="Garamond"/>
-              </a:rPr>
+            <a:r>
               <a:t>Links &amp; Sources</a:t>
             </a:r>
           </a:p>
           <a:p>
-            <a:pPr algn="l" indent="-152400" marL="177800">
-              <a:spcBef>
-                <a:spcPts val="0"/>
-              </a:spcBef>
-              <a:spcAft>
-                <a:spcPts val="100"/>
-              </a:spcAft>
-              <a:buFont typeface="Garamond"/>
-              <a:buChar char="•"/>
-            </a:pPr>
-            <a:r>
-              <a:rPr sz="650" b="0" i="0">
-                <a:solidFill>
-                  <a:srgbClr val="262626"/>
-                </a:solidFill>
-                <a:latin typeface="Garamond"/>
-                <a:cs typeface="Garamond"/>
-              </a:rPr>
+            <a:r>
               <a:t>[1] LULU_DCF_Valuation_Model.xlsx, Bear Case DCF Valuation Summary / https://www.barrons.com/articles/lululemon-stock-earnings-guidance-a7a7c5c0</a:t>
             </a:r>
           </a:p>
           <a:p>
-            <a:pPr algn="l" indent="-152400" marL="177800">
-              <a:spcBef>
-                <a:spcPts val="0"/>
-              </a:spcBef>
-              <a:spcAft>
-                <a:spcPts val="100"/>
-              </a:spcAft>
-              <a:buFont typeface="Garamond"/>
-              <a:buChar char="•"/>
-            </a:pPr>
-            <a:r>
-              <a:rPr sz="650" b="0" i="0">
-                <a:solidFill>
-                  <a:srgbClr val="262626"/>
-                </a:solidFill>
-                <a:latin typeface="Garamond"/>
-                <a:cs typeface="Garamond"/>
-              </a:rPr>
-              <a:t>[2] LULU_DCF_Valuation_Model.xlsx, CapEx Fade &amp; NWC Schedule / NOPAT Bridge (E-Commerce EBIT Margin) / https://corporate.lululemon.com/newsroom/press-releases/2026/09-03-2026-210528733</a:t>
-            </a:r>
-          </a:p>
-          <a:p>
-            <a:pPr algn="l" indent="-152400" marL="177800">
-              <a:spcBef>
-                <a:spcPts val="0"/>
-              </a:spcBef>
-              <a:spcAft>
-                <a:spcPts val="100"/>
-              </a:spcAft>
-              <a:buFont typeface="Garamond"/>
-              <a:buChar char="•"/>
-            </a:pPr>
-            <a:r>
-              <a:rPr sz="650" b="0" i="0">
-                <a:solidFill>
-                  <a:srgbClr val="262626"/>
-                </a:solidFill>
-                <a:latin typeface="Garamond"/>
-                <a:cs typeface="Garamond"/>
-              </a:rPr>
+            <a:r>
+              <a:t>[2] LULU_DCF_Valuation_Model.xlsx, CapEx Fade &amp; NWC Schedule/ https://corporate.lululemon.com/newsroom/press-releases/2026/09-03-2026-210528733</a:t>
+            </a:r>
+          </a:p>
+          <a:p>
+            <a:r>
               <a:t>[3] LULU_DCF_Valuation_Model.xlsx, Share Repurchase &amp; EPS Accretion Schedule / https://corporate.lululemon.com/newsroom/press-releases/2026/09-03-2026-210528733</a:t>
             </a:r>
           </a:p>
@@ -6598,27 +6426,7 @@
             <a:spAutoFit/>
           </a:bodyPr>
           <a:lstStyle/>
-          <a:p>
-            <a:pPr algn="l">
-              <a:spcBef>
-                <a:spcPts val="0"/>
-              </a:spcBef>
-              <a:spcAft>
-                <a:spcPts val="0"/>
-              </a:spcAft>
-              <a:buNone/>
-            </a:pPr>
-            <a:r>
-              <a:rPr sz="800" b="0" i="0">
-                <a:solidFill>
-                  <a:srgbClr val="8C8C8C"/>
-                </a:solidFill>
-                <a:latin typeface="Garamond"/>
-                <a:cs typeface="Garamond"/>
-              </a:rPr>
-              <a:t> </a:t>
-            </a:r>
-          </a:p>
+          <a:p/>
         </p:txBody>
       </p:sp>
       <p:sp>
@@ -7071,111 +6879,27 @@
           </a:bodyPr>
           <a:lstStyle/>
           <a:p>
-            <a:pPr algn="l">
-              <a:spcBef>
-                <a:spcPts val="0"/>
-              </a:spcBef>
-              <a:spcAft>
-                <a:spcPts val="100"/>
-              </a:spcAft>
-              <a:buNone/>
-            </a:pPr>
-            <a:r>
-              <a:rPr sz="800" b="1" i="0">
-                <a:solidFill>
-                  <a:srgbClr val="990000"/>
-                </a:solidFill>
-                <a:latin typeface="Garamond"/>
-                <a:cs typeface="Garamond"/>
-              </a:rPr>
+            <a:r>
               <a:t>Links &amp; Sources</a:t>
             </a:r>
           </a:p>
           <a:p>
-            <a:pPr algn="l" indent="-152400" marL="177800">
-              <a:spcBef>
-                <a:spcPts val="0"/>
-              </a:spcBef>
-              <a:spcAft>
-                <a:spcPts val="100"/>
-              </a:spcAft>
-              <a:buFont typeface="Garamond"/>
-              <a:buChar char="•"/>
-            </a:pPr>
-            <a:r>
-              <a:rPr sz="650" b="0" i="0">
-                <a:solidFill>
-                  <a:srgbClr val="262626"/>
-                </a:solidFill>
-                <a:latin typeface="Garamond"/>
-                <a:cs typeface="Garamond"/>
-              </a:rPr>
+            <a:r>
               <a:t>[1] LULU_DCF_Valuation_Model.xlsx, Scenarios &amp; Revenue Drivers / https://corporate.lululemon.com/newsroom/press-releases/2026/09-03-2026-210528733</a:t>
             </a:r>
           </a:p>
           <a:p>
-            <a:pPr algn="l" indent="-152400" marL="177800">
-              <a:spcBef>
-                <a:spcPts val="0"/>
-              </a:spcBef>
-              <a:spcAft>
-                <a:spcPts val="100"/>
-              </a:spcAft>
-              <a:buFont typeface="Garamond"/>
-              <a:buChar char="•"/>
-            </a:pPr>
-            <a:r>
-              <a:rPr sz="650" b="0" i="0">
-                <a:solidFill>
-                  <a:srgbClr val="262626"/>
-                </a:solidFill>
-                <a:latin typeface="Garamond"/>
-                <a:cs typeface="Garamond"/>
-              </a:rPr>
-              <a:t>[2] LULU_DCF_Valuation_Model.xlsx, NOPAT Bridge &amp; Scenarios / https://corporate.lululemon.com/newsroom/press-releases/2026/09-03-2026-210528733</a:t>
-            </a:r>
-          </a:p>
-          <a:p>
-            <a:pPr algn="l" indent="-152400" marL="177800">
-              <a:spcBef>
-                <a:spcPts val="0"/>
-              </a:spcBef>
-              <a:spcAft>
-                <a:spcPts val="100"/>
-              </a:spcAft>
-              <a:buFont typeface="Garamond"/>
-              <a:buChar char="•"/>
-            </a:pPr>
-            <a:r>
-              <a:rPr sz="650" b="0" i="0">
-                <a:solidFill>
-                  <a:srgbClr val="262626"/>
-                </a:solidFill>
-                <a:latin typeface="Garamond"/>
-                <a:cs typeface="Garamond"/>
-              </a:rPr>
+            <a:r>
+              <a:t>[2] LULU_DCF_Valuation_Model.xlsx, Scenarios / https://corporate.lululemon.com/newsroom/press-releases/2026/09-03-2026-210528733</a:t>
+            </a:r>
+          </a:p>
+          <a:p>
+            <a:r>
               <a:t>[3] LULU_DCF_Valuation_Model.xlsx, Scenarios &amp; Unlevered Free Cash Flow Schedule / https://corporate.lululemon.com/newsroom/press-releases/2026/09-03-2026-210528733</a:t>
             </a:r>
           </a:p>
           <a:p>
-            <a:pPr algn="l" indent="-152400" marL="177800">
-              <a:spcBef>
-                <a:spcPts val="0"/>
-              </a:spcBef>
-              <a:spcAft>
-                <a:spcPts val="100"/>
-              </a:spcAft>
-              <a:buFont typeface="Garamond"/>
-              <a:buChar char="•"/>
-            </a:pPr>
-            <a:r>
-              <a:rPr sz="650" b="0" i="0">
-                <a:solidFill>
-                  <a:srgbClr val="262626"/>
-                </a:solidFill>
-                <a:latin typeface="Garamond"/>
-                <a:cs typeface="Garamond"/>
-              </a:rPr>
+            <a:r>
               <a:t>[4] LULU_DCF_Valuation_Model.xlsx, Revenue Drivers &amp; DCF Valuation Summary / https://stockanalysis.com/stocks/lulu/forecast/</a:t>
             </a:r>
           </a:p>
@@ -19689,27 +19413,7 @@
             <a:spAutoFit/>
           </a:bodyPr>
           <a:lstStyle/>
-          <a:p>
-            <a:pPr algn="l">
-              <a:spcBef>
-                <a:spcPts val="0"/>
-              </a:spcBef>
-              <a:spcAft>
-                <a:spcPts val="0"/>
-              </a:spcAft>
-              <a:buNone/>
-            </a:pPr>
-            <a:r>
-              <a:rPr sz="800" b="0" i="0">
-                <a:solidFill>
-                  <a:srgbClr val="8C8C8C"/>
-                </a:solidFill>
-                <a:latin typeface="Garamond"/>
-                <a:cs typeface="Garamond"/>
-              </a:rPr>
-              <a:t> </a:t>
-            </a:r>
-          </a:p>
+          <a:p/>
         </p:txBody>
       </p:sp>
       <p:sp>
@@ -20382,16 +20086,8 @@
                     </a:bodyPr>
                     <a:lstStyle/>
                     <a:p>
-                      <a:pPr algn="l"/>
-                      <a:r>
-                        <a:rPr sz="900" b="0" i="0">
-                          <a:solidFill>
-                            <a:srgbClr val="262626"/>
-                          </a:solidFill>
-                          <a:latin typeface="Garamond"/>
-                          <a:cs typeface="Garamond"/>
-                        </a:rPr>
-                        <a:t>Investment Thesis II  Partial Margin Recovery &amp; Brand Loyalty Floor</a:t>
+                      <a:r>
+                        <a:t>Investment Thesis II Partial Margin Recovery &amp; Brand Loyalty Floor</a:t>
                       </a:r>
                     </a:p>
                   </a:txBody>
@@ -24037,230 +23733,48 @@
           <a:bodyPr rtlCol="0" anchor="ctr" wrap="square"/>
           <a:lstStyle/>
           <a:p>
-            <a:pPr algn="l">
-              <a:spcBef>
-                <a:spcPts val="0"/>
-              </a:spcBef>
-              <a:spcAft>
-                <a:spcPts val="500"/>
-              </a:spcAft>
-              <a:buNone/>
-            </a:pPr>
-            <a:r>
-              <a:rPr sz="1100" b="1" i="0">
-                <a:solidFill>
-                  <a:srgbClr val="990000"/>
-                </a:solidFill>
-                <a:latin typeface="Garamond"/>
-                <a:cs typeface="Garamond"/>
-              </a:rPr>
+            <a:r>
               <a:t>VALUATION OUTPUT (US$ M)</a:t>
             </a:r>
           </a:p>
           <a:p>
-            <a:pPr>
-              <a:spcAft>
-                <a:spcPts val="300"/>
-              </a:spcAft>
-            </a:pPr>
-            <a:r>
-              <a:rPr sz="1050" b="0" i="0">
-                <a:solidFill>
-                  <a:srgbClr val="262626"/>
-                </a:solidFill>
-                <a:latin typeface="Garamond"/>
-                <a:cs typeface="Garamond"/>
-              </a:rPr>
-              <a:t>PV of explicit FCF (FY26-FY30)</a:t>
-            </a:r>
-            <a:r>
-              <a:rPr sz="1050" b="1" i="0">
-                <a:solidFill>
-                  <a:srgbClr val="1F2A44"/>
-                </a:solidFill>
-                <a:latin typeface="Garamond"/>
-                <a:cs typeface="Garamond"/>
-              </a:rPr>
-              <a:t>  3,930</a:t>
-            </a:r>
-          </a:p>
-          <a:p>
-            <a:pPr>
-              <a:spcAft>
-                <a:spcPts val="300"/>
-              </a:spcAft>
-            </a:pPr>
-            <a:r>
-              <a:rPr sz="1050" b="0" i="0">
-                <a:solidFill>
-                  <a:srgbClr val="262626"/>
-                </a:solidFill>
-                <a:latin typeface="Garamond"/>
-                <a:cs typeface="Garamond"/>
-              </a:rPr>
-              <a:t>PV of terminal value</a:t>
-            </a:r>
-            <a:r>
-              <a:rPr sz="1050" b="1" i="0">
-                <a:solidFill>
-                  <a:srgbClr val="1F2A44"/>
-                </a:solidFill>
-                <a:latin typeface="Garamond"/>
-                <a:cs typeface="Garamond"/>
-              </a:rPr>
-              <a:t>  10,933</a:t>
-            </a:r>
-          </a:p>
-          <a:p>
-            <a:pPr>
-              <a:spcAft>
-                <a:spcPts val="300"/>
-              </a:spcAft>
-            </a:pPr>
-            <a:r>
-              <a:rPr sz="1050" b="1" i="0">
-                <a:solidFill>
-                  <a:srgbClr val="262626"/>
-                </a:solidFill>
-                <a:latin typeface="Garamond"/>
-                <a:cs typeface="Garamond"/>
-              </a:rPr>
-              <a:t>Enterprise value</a:t>
-            </a:r>
-            <a:r>
-              <a:rPr sz="1050" b="1" i="0">
-                <a:solidFill>
-                  <a:srgbClr val="1F2A44"/>
-                </a:solidFill>
-                <a:latin typeface="Garamond"/>
-                <a:cs typeface="Garamond"/>
-              </a:rPr>
-              <a:t>  14,862</a:t>
-            </a:r>
-          </a:p>
-          <a:p>
-            <a:pPr>
-              <a:spcAft>
-                <a:spcPts val="300"/>
-              </a:spcAft>
-            </a:pPr>
-            <a:r>
-              <a:rPr sz="1050" b="0" i="0">
-                <a:solidFill>
-                  <a:srgbClr val="262626"/>
-                </a:solidFill>
-                <a:latin typeface="Garamond"/>
-                <a:cs typeface="Garamond"/>
-              </a:rPr>
-              <a:t>Plus: cash</a:t>
-            </a:r>
-            <a:r>
-              <a:rPr sz="1050" b="1" i="0">
-                <a:solidFill>
-                  <a:srgbClr val="1F2A44"/>
-                </a:solidFill>
-                <a:latin typeface="Garamond"/>
-                <a:cs typeface="Garamond"/>
-              </a:rPr>
-              <a:t>  1,807</a:t>
-            </a:r>
-          </a:p>
-          <a:p>
-            <a:pPr>
-              <a:spcAft>
-                <a:spcPts val="300"/>
-              </a:spcAft>
-            </a:pPr>
-            <a:r>
-              <a:rPr sz="1050" b="0" i="0">
-                <a:solidFill>
-                  <a:srgbClr val="262626"/>
-                </a:solidFill>
-                <a:latin typeface="Garamond"/>
-                <a:cs typeface="Garamond"/>
-              </a:rPr>
-              <a:t>Less: lease debt (ASC 842)</a:t>
-            </a:r>
-            <a:r>
-              <a:rPr sz="1050" b="1" i="0">
-                <a:solidFill>
-                  <a:srgbClr val="1F2A44"/>
-                </a:solidFill>
-                <a:latin typeface="Garamond"/>
-                <a:cs typeface="Garamond"/>
-              </a:rPr>
-              <a:t>  (1,798)</a:t>
-            </a:r>
-          </a:p>
-          <a:p>
-            <a:pPr>
-              <a:spcAft>
-                <a:spcPts val="300"/>
-              </a:spcAft>
-            </a:pPr>
-            <a:r>
-              <a:rPr sz="1050" b="1" i="0">
-                <a:solidFill>
-                  <a:srgbClr val="262626"/>
-                </a:solidFill>
-                <a:latin typeface="Garamond"/>
-                <a:cs typeface="Garamond"/>
-              </a:rPr>
-              <a:t>Equity value</a:t>
-            </a:r>
-            <a:r>
-              <a:rPr sz="1050" b="1" i="0">
-                <a:solidFill>
-                  <a:srgbClr val="1F2A44"/>
-                </a:solidFill>
-                <a:latin typeface="Garamond"/>
-                <a:cs typeface="Garamond"/>
-              </a:rPr>
-              <a:t>  14,871</a:t>
-            </a:r>
-          </a:p>
-          <a:p>
-            <a:pPr>
-              <a:spcAft>
-                <a:spcPts val="300"/>
-              </a:spcAft>
-            </a:pPr>
-            <a:r>
-              <a:rPr sz="1050" b="0" i="0">
-                <a:solidFill>
-                  <a:srgbClr val="262626"/>
-                </a:solidFill>
-                <a:latin typeface="Garamond"/>
-                <a:cs typeface="Garamond"/>
-              </a:rPr>
-              <a:t>÷ Diluted shares (M)</a:t>
-            </a:r>
-            <a:r>
-              <a:rPr sz="1050" b="1" i="0">
-                <a:solidFill>
-                  <a:srgbClr val="1F2A44"/>
-                </a:solidFill>
-                <a:latin typeface="Garamond"/>
-                <a:cs typeface="Garamond"/>
-              </a:rPr>
-              <a:t>  111.4</a:t>
-            </a:r>
-          </a:p>
-          <a:p>
-            <a:pPr>
-              <a:spcBef>
-                <a:spcPts val="400"/>
-              </a:spcBef>
-            </a:pPr>
-            <a:r>
-              <a:rPr sz="1500" b="1" i="0">
-                <a:solidFill>
-                  <a:srgbClr val="1E7A3C"/>
-                </a:solidFill>
-                <a:latin typeface="Garamond"/>
-                <a:cs typeface="Garamond"/>
-              </a:rPr>
-              <a:t>Implied value:  $133.52 / share</a:t>
+            <a:r>
+              <a:t>PV of explicit FCF (FY26-FY30) 3,930</a:t>
+            </a:r>
+          </a:p>
+          <a:p>
+            <a:r>
+              <a:t>PV of terminal value 10,933</a:t>
+            </a:r>
+          </a:p>
+          <a:p>
+            <a:r>
+              <a:t>Enterprise value 14,862</a:t>
+            </a:r>
+          </a:p>
+          <a:p>
+            <a:r>
+              <a:t>Plus: cash 1,807</a:t>
+            </a:r>
+          </a:p>
+          <a:p>
+            <a:r>
+              <a:t>Less: lease debt (ASC 842) (1,798)</a:t>
+            </a:r>
+          </a:p>
+          <a:p>
+            <a:r>
+              <a:t>Equity value 14,871</a:t>
+            </a:r>
+          </a:p>
+          <a:p>
+            <a:r>
+              <a:t>÷ Diluted shares (M) 111.4</a:t>
+            </a:r>
+          </a:p>
+          <a:p>
+            <a:r>
+              <a:t>Implied value: $133.52 / share</a:t>
             </a:r>
           </a:p>
         </p:txBody>
@@ -24291,44 +23805,12 @@
           <a:bodyPr rtlCol="0" anchor="ctr" wrap="square"/>
           <a:lstStyle/>
           <a:p>
-            <a:pPr algn="l">
-              <a:spcBef>
-                <a:spcPts val="0"/>
-              </a:spcBef>
-              <a:spcAft>
-                <a:spcPts val="300"/>
-              </a:spcAft>
-              <a:buNone/>
-            </a:pPr>
-            <a:r>
-              <a:rPr sz="800" b="1" i="0">
-                <a:solidFill>
-                  <a:srgbClr val="FFFFFF"/>
-                </a:solidFill>
-                <a:latin typeface="Garamond"/>
-                <a:cs typeface="Garamond"/>
-              </a:rPr>
-              <a:t>TV = 73% of EV  ·  7.4x = Gordon TV ÷ FY30 EBITDA $2,284M (not a peer pick)</a:t>
-            </a:r>
-          </a:p>
-          <a:p>
-            <a:pPr algn="l">
-              <a:spcBef>
-                <a:spcPts val="0"/>
-              </a:spcBef>
-              <a:spcAft>
-                <a:spcPts val="0"/>
-              </a:spcAft>
-              <a:buNone/>
-            </a:pPr>
-            <a:r>
-              <a:rPr sz="800" b="0" i="0">
-                <a:solidFill>
-                  <a:srgbClr val="FFFFFF"/>
-                </a:solidFill>
-                <a:latin typeface="Garamond"/>
-                <a:cs typeface="Garamond"/>
-              </a:rPr>
+            <a:r>
+              <a:t>TV = 73% of EV · 7.4x = Gordon TV ÷ FY30 EBITDA $2,284M (not a peer pick)</a:t>
+            </a:r>
+          </a:p>
+          <a:p>
+            <a:r>
               <a:t>Selected TV is Gordon growth (g). The 7.4x exit multiple is the identity check (TV ÷ FY30 EBITDA), not a peer average</a:t>
             </a:r>
           </a:p>
@@ -29059,65 +28541,17 @@
           <a:bodyPr rtlCol="0" anchor="ctr" wrap="square"/>
           <a:lstStyle/>
           <a:p>
-            <a:pPr algn="l">
-              <a:spcBef>
-                <a:spcPts val="0"/>
-              </a:spcBef>
-              <a:spcAft>
-                <a:spcPts val="400"/>
-              </a:spcAft>
-              <a:buNone/>
-            </a:pPr>
-            <a:r>
-              <a:rPr sz="850" b="1" i="0">
-                <a:solidFill>
-                  <a:srgbClr val="990000"/>
-                </a:solidFill>
-                <a:latin typeface="Garamond"/>
-                <a:cs typeface="Garamond"/>
-              </a:rPr>
+            <a:r>
               <a:t>Valuation anchors</a:t>
             </a:r>
           </a:p>
           <a:p>
-            <a:pPr algn="l">
-              <a:spcBef>
-                <a:spcPts val="0"/>
-              </a:spcBef>
-              <a:spcAft>
-                <a:spcPts val="300"/>
-              </a:spcAft>
-              <a:buNone/>
-            </a:pPr>
-            <a:r>
-              <a:rPr sz="850" b="1" i="0">
-                <a:solidFill>
-                  <a:srgbClr val="1F2A44"/>
-                </a:solidFill>
-                <a:latin typeface="Garamond"/>
-                <a:cs typeface="Garamond"/>
-              </a:rPr>
-              <a:t>DCF base: $133.52  |  Target: $140</a:t>
-            </a:r>
-          </a:p>
-          <a:p>
-            <a:pPr algn="l">
-              <a:spcBef>
-                <a:spcPts val="0"/>
-              </a:spcBef>
-              <a:spcAft>
-                <a:spcPts val="0"/>
-              </a:spcAft>
-              <a:buNone/>
-            </a:pPr>
-            <a:r>
-              <a:rPr sz="850" b="0" i="1">
-                <a:solidFill>
-                  <a:srgbClr val="262626"/>
-                </a:solidFill>
-                <a:latin typeface="Garamond"/>
-                <a:cs typeface="Garamond"/>
-              </a:rPr>
+            <a:r>
+              <a:t>DCF base: $133.52 | Target: $140</a:t>
+            </a:r>
+          </a:p>
+          <a:p>
+            <a:r>
               <a:t>Private precedents inform strategic context only; public comps on the prior slide</a:t>
             </a:r>
           </a:p>
@@ -29341,27 +28775,7 @@
             <a:spAutoFit/>
           </a:bodyPr>
           <a:lstStyle/>
-          <a:p>
-            <a:pPr algn="l">
-              <a:spcBef>
-                <a:spcPts val="0"/>
-              </a:spcBef>
-              <a:spcAft>
-                <a:spcPts val="0"/>
-              </a:spcAft>
-              <a:buNone/>
-            </a:pPr>
-            <a:r>
-              <a:rPr sz="800" b="0" i="0">
-                <a:solidFill>
-                  <a:srgbClr val="8C8C8C"/>
-                </a:solidFill>
-                <a:latin typeface="Garamond"/>
-                <a:cs typeface="Garamond"/>
-              </a:rPr>
-              <a:t> </a:t>
-            </a:r>
-          </a:p>
+          <a:p/>
         </p:txBody>
       </p:sp>
       <p:sp>
@@ -30174,27 +29588,7 @@
             <a:spAutoFit/>
           </a:bodyPr>
           <a:lstStyle/>
-          <a:p>
-            <a:pPr algn="l">
-              <a:spcBef>
-                <a:spcPts val="0"/>
-              </a:spcBef>
-              <a:spcAft>
-                <a:spcPts val="0"/>
-              </a:spcAft>
-              <a:buNone/>
-            </a:pPr>
-            <a:r>
-              <a:rPr sz="800" b="0" i="0">
-                <a:solidFill>
-                  <a:srgbClr val="8C8C8C"/>
-                </a:solidFill>
-                <a:latin typeface="Garamond"/>
-                <a:cs typeface="Garamond"/>
-              </a:rPr>
-              <a:t> </a:t>
-            </a:r>
-          </a:p>
+          <a:p/>
         </p:txBody>
       </p:sp>
       <p:sp>
@@ -30881,27 +30275,7 @@
             <a:spAutoFit/>
           </a:bodyPr>
           <a:lstStyle/>
-          <a:p>
-            <a:pPr algn="l">
-              <a:spcBef>
-                <a:spcPts val="0"/>
-              </a:spcBef>
-              <a:spcAft>
-                <a:spcPts val="0"/>
-              </a:spcAft>
-              <a:buNone/>
-            </a:pPr>
-            <a:r>
-              <a:rPr sz="800" b="0" i="0">
-                <a:solidFill>
-                  <a:srgbClr val="8C8C8C"/>
-                </a:solidFill>
-                <a:latin typeface="Garamond"/>
-                <a:cs typeface="Garamond"/>
-              </a:rPr>
-              <a:t> </a:t>
-            </a:r>
-          </a:p>
+          <a:p/>
         </p:txBody>
       </p:sp>
       <p:sp>
@@ -31714,27 +31088,7 @@
             <a:spAutoFit/>
           </a:bodyPr>
           <a:lstStyle/>
-          <a:p>
-            <a:pPr algn="l">
-              <a:spcBef>
-                <a:spcPts val="0"/>
-              </a:spcBef>
-              <a:spcAft>
-                <a:spcPts val="0"/>
-              </a:spcAft>
-              <a:buNone/>
-            </a:pPr>
-            <a:r>
-              <a:rPr sz="800" b="0" i="0">
-                <a:solidFill>
-                  <a:srgbClr val="8C8C8C"/>
-                </a:solidFill>
-                <a:latin typeface="Garamond"/>
-                <a:cs typeface="Garamond"/>
-              </a:rPr>
-              <a:t> </a:t>
-            </a:r>
-          </a:p>
+          <a:p/>
         </p:txBody>
       </p:sp>
       <p:sp>
@@ -32421,27 +31775,7 @@
             <a:spAutoFit/>
           </a:bodyPr>
           <a:lstStyle/>
-          <a:p>
-            <a:pPr algn="l">
-              <a:spcBef>
-                <a:spcPts val="0"/>
-              </a:spcBef>
-              <a:spcAft>
-                <a:spcPts val="0"/>
-              </a:spcAft>
-              <a:buNone/>
-            </a:pPr>
-            <a:r>
-              <a:rPr sz="800" b="0" i="0">
-                <a:solidFill>
-                  <a:srgbClr val="8C8C8C"/>
-                </a:solidFill>
-                <a:latin typeface="Garamond"/>
-                <a:cs typeface="Garamond"/>
-              </a:rPr>
-              <a:t> </a:t>
-            </a:r>
-          </a:p>
+          <a:p/>
         </p:txBody>
       </p:sp>
       <p:sp>
@@ -33128,27 +32462,7 @@
             <a:spAutoFit/>
           </a:bodyPr>
           <a:lstStyle/>
-          <a:p>
-            <a:pPr algn="l">
-              <a:spcBef>
-                <a:spcPts val="0"/>
-              </a:spcBef>
-              <a:spcAft>
-                <a:spcPts val="0"/>
-              </a:spcAft>
-              <a:buNone/>
-            </a:pPr>
-            <a:r>
-              <a:rPr sz="800" b="0" i="0">
-                <a:solidFill>
-                  <a:srgbClr val="8C8C8C"/>
-                </a:solidFill>
-                <a:latin typeface="Garamond"/>
-                <a:cs typeface="Garamond"/>
-              </a:rPr>
-              <a:t> </a:t>
-            </a:r>
-          </a:p>
+          <a:p/>
         </p:txBody>
       </p:sp>
       <p:sp>
@@ -33835,27 +33149,7 @@
             <a:spAutoFit/>
           </a:bodyPr>
           <a:lstStyle/>
-          <a:p>
-            <a:pPr algn="l">
-              <a:spcBef>
-                <a:spcPts val="0"/>
-              </a:spcBef>
-              <a:spcAft>
-                <a:spcPts val="0"/>
-              </a:spcAft>
-              <a:buNone/>
-            </a:pPr>
-            <a:r>
-              <a:rPr sz="800" b="0" i="0">
-                <a:solidFill>
-                  <a:srgbClr val="8C8C8C"/>
-                </a:solidFill>
-                <a:latin typeface="Garamond"/>
-                <a:cs typeface="Garamond"/>
-              </a:rPr>
-              <a:t> </a:t>
-            </a:r>
-          </a:p>
+          <a:p/>
         </p:txBody>
       </p:sp>
       <p:sp>

</xml_diff>